<commit_message>
Presentacion: completar la diapositiva de la Pregunta 2
Llena los dos hallazgos y la implicacion de distribucion y trazabilidad territorial, y marca el espacio del mapa por departamento.
</commit_message>
<xml_diff>
--- a/Entregables/Plantilla_Presentacion_Proyecto_1_INVIAS.pptx
+++ b/Entregables/Plantilla_Presentacion_Proyecto_1_INVIAS.pptx
@@ -4302,7 +4302,7 @@
               </a:defRPr>
             </a:pPr>
             <a:r>
-              <a:t>VISUALIZACIÓN TERRITORIAL PRINCIPAL</a:t>
+              <a:t>MAPA DE VALOR CONTRATADO POR DEPARTAMENTO</a:t>
             </a:r>
           </a:p>
         </p:txBody>
@@ -4398,7 +4398,7 @@
               </a:defRPr>
             </a:pPr>
             <a:r>
-              <a:t>[Cifra / hallazgo territorial]</a:t>
+              <a:t>43 % de los contratos puede ubicarse en un departamento, pero concentra el 77,9 % del valor. Lo no ubicable es el 56,7 % de los registros y solo el 22,1 % del dinero.</a:t>
             </a:r>
           </a:p>
         </p:txBody>
@@ -4494,7 +4494,7 @@
               </a:defRPr>
             </a:pPr>
             <a:r>
-              <a:t>[Cifra / hallazgo territorial]</a:t>
+              <a:t>La trazabilidad se está perdiendo: 85–95 % entre 2018 y 2022, 76 % en 2023 y 2024, y 46 % en 2025.</a:t>
             </a:r>
           </a:p>
         </p:txBody>
@@ -4590,7 +4590,7 @@
               </a:defRPr>
             </a:pPr>
             <a:r>
-              <a:t>[Una frase ejecutiva]</a:t>
+              <a:t>Uno de cada cinco pesos no es rastreable territorialmente desde lo que publica el SECOP II.</a:t>
             </a:r>
           </a:p>
         </p:txBody>

</xml_diff>

<commit_message>
Agregar las figuras de la Pregunta 2 al reporte y la presentacion
Inserta el mapa de valor contratado por departamento y la evolucion anual de la trazabilidad en la seccion 2 del reporte, y el mapa en la diapositiva 3. Se ajusto el texto de la seccion 2 para que quepa en una pagina.
</commit_message>
<xml_diff>
--- a/Entregables/Plantilla_Presentacion_Proyecto_1_INVIAS.pptx
+++ b/Entregables/Plantilla_Presentacion_Proyecto_1_INVIAS.pptx
@@ -4630,6 +4630,30 @@
           </a:p>
         </p:txBody>
       </p:sp>
+      <p:pic>
+        <p:nvPicPr>
+          <p:cNvPr id="14" name="Picture 13" descr="mapa_slide.png"/>
+          <p:cNvPicPr>
+            <a:picLocks noChangeAspect="1"/>
+          </p:cNvPicPr>
+          <p:nvPr/>
+        </p:nvPicPr>
+        <p:blipFill>
+          <a:blip r:embed="rId3"/>
+          <a:stretch>
+            <a:fillRect/>
+          </a:stretch>
+        </p:blipFill>
+        <p:spPr>
+          <a:xfrm>
+            <a:off x="2614462" y="2103120"/>
+            <a:ext cx="2634915" cy="3337560"/>
+          </a:xfrm>
+          <a:prstGeom prst="rect">
+            <a:avLst/>
+          </a:prstGeom>
+        </p:spPr>
+      </p:pic>
     </p:spTree>
   </p:cSld>
   <p:clrMapOvr>

</xml_diff>